<commit_message>
Drop DPT fusion labels from tracking head diagram
</commit_message>
<xml_diff>
--- a/labs_forum/track_head.pptx
+++ b/labs_forum/track_head.pptx
@@ -3375,42 +3375,7 @@
       </p:cxnSp>
       <p:sp>
         <p:nvSpPr>
-          <p:cNvPr id="8" name="TextBox 7"/>
-          <p:cNvSpPr txBox="1"/>
-          <p:nvPr/>
-        </p:nvSpPr>
-        <p:spPr>
-          <a:xfrm>
-            <a:off x="3708000" y="360000"/>
-            <a:ext cx="2160000" cy="251999"/>
-          </a:xfrm>
-          <a:prstGeom prst="rect">
-            <a:avLst/>
-          </a:prstGeom>
-          <a:noFill/>
-        </p:spPr>
-        <p:txBody>
-          <a:bodyPr wrap="square" lIns="0" rIns="0" tIns="0" bIns="0" anchor="ctr">
-            <a:spAutoFit/>
-          </a:bodyPr>
-          <a:lstStyle/>
-          <a:p>
-            <a:pPr algn="l"/>
-            <a:r>
-              <a:rPr sz="1500" b="1" i="0">
-                <a:solidFill>
-                  <a:srgbClr val="B5412F"/>
-                </a:solidFill>
-                <a:latin typeface="Work Sans"/>
-              </a:rPr>
-              <a:t>DPT Fusion</a:t>
-            </a:r>
-          </a:p>
-        </p:txBody>
-      </p:sp>
-      <p:sp>
-        <p:nvSpPr>
-          <p:cNvPr id="9" name="Left Bracket 8"/>
+          <p:cNvPr id="8" name="Left Bracket 7"/>
           <p:cNvSpPr/>
           <p:nvPr/>
         </p:nvSpPr>
@@ -3454,7 +3419,7 @@
       </p:sp>
       <p:grpSp>
         <p:nvGrpSpPr>
-          <p:cNvPr id="10" name="Group 9"/>
+          <p:cNvPr id="9" name="Group 8"/>
           <p:cNvGrpSpPr/>
           <p:nvPr/>
         </p:nvGrpSpPr>
@@ -3468,7 +3433,7 @@
         </p:grpSpPr>
         <p:sp>
           <p:nvSpPr>
-            <p:cNvPr id="11" name="Rectangle 10"/>
+            <p:cNvPr id="10" name="Rectangle 9"/>
             <p:cNvSpPr/>
             <p:nvPr/>
           </p:nvSpPr>
@@ -3514,7 +3479,7 @@
         </p:sp>
         <p:cxnSp>
           <p:nvCxnSpPr>
-            <p:cNvPr id="12" name="Connector 11"/>
+            <p:cNvPr id="11" name="Connector 10"/>
             <p:cNvCxnSpPr/>
             <p:nvPr/>
           </p:nvCxnSpPr>
@@ -3549,7 +3514,7 @@
         </p:cxnSp>
         <p:cxnSp>
           <p:nvCxnSpPr>
-            <p:cNvPr id="13" name="Connector 12"/>
+            <p:cNvPr id="12" name="Connector 11"/>
             <p:cNvCxnSpPr/>
             <p:nvPr/>
           </p:nvCxnSpPr>
@@ -3584,7 +3549,7 @@
         </p:cxnSp>
         <p:cxnSp>
           <p:nvCxnSpPr>
-            <p:cNvPr id="14" name="Connector 13"/>
+            <p:cNvPr id="13" name="Connector 12"/>
             <p:cNvCxnSpPr/>
             <p:nvPr/>
           </p:nvCxnSpPr>
@@ -3619,7 +3584,7 @@
         </p:cxnSp>
         <p:cxnSp>
           <p:nvCxnSpPr>
-            <p:cNvPr id="15" name="Connector 14"/>
+            <p:cNvPr id="14" name="Connector 13"/>
             <p:cNvCxnSpPr/>
             <p:nvPr/>
           </p:nvCxnSpPr>
@@ -3654,7 +3619,7 @@
         </p:cxnSp>
         <p:cxnSp>
           <p:nvCxnSpPr>
-            <p:cNvPr id="16" name="Connector 15"/>
+            <p:cNvPr id="15" name="Connector 14"/>
             <p:cNvCxnSpPr/>
             <p:nvPr/>
           </p:nvCxnSpPr>
@@ -3689,7 +3654,7 @@
         </p:cxnSp>
         <p:cxnSp>
           <p:nvCxnSpPr>
-            <p:cNvPr id="17" name="Connector 16"/>
+            <p:cNvPr id="16" name="Connector 15"/>
             <p:cNvCxnSpPr/>
             <p:nvPr/>
           </p:nvCxnSpPr>
@@ -3725,7 +3690,7 @@
       </p:grpSp>
       <p:grpSp>
         <p:nvGrpSpPr>
-          <p:cNvPr id="18" name="Group 17"/>
+          <p:cNvPr id="17" name="Group 16"/>
           <p:cNvGrpSpPr/>
           <p:nvPr/>
         </p:nvGrpSpPr>
@@ -3739,7 +3704,7 @@
         </p:grpSpPr>
         <p:sp>
           <p:nvSpPr>
-            <p:cNvPr id="19" name="Rectangle 18"/>
+            <p:cNvPr id="18" name="Rectangle 17"/>
             <p:cNvSpPr/>
             <p:nvPr/>
           </p:nvSpPr>
@@ -3785,7 +3750,7 @@
         </p:sp>
         <p:cxnSp>
           <p:nvCxnSpPr>
-            <p:cNvPr id="20" name="Connector 19"/>
+            <p:cNvPr id="19" name="Connector 18"/>
             <p:cNvCxnSpPr/>
             <p:nvPr/>
           </p:nvCxnSpPr>
@@ -3820,7 +3785,7 @@
         </p:cxnSp>
         <p:cxnSp>
           <p:nvCxnSpPr>
-            <p:cNvPr id="21" name="Connector 20"/>
+            <p:cNvPr id="20" name="Connector 19"/>
             <p:cNvCxnSpPr/>
             <p:nvPr/>
           </p:nvCxnSpPr>
@@ -3855,7 +3820,7 @@
         </p:cxnSp>
         <p:cxnSp>
           <p:nvCxnSpPr>
-            <p:cNvPr id="22" name="Connector 21"/>
+            <p:cNvPr id="21" name="Connector 20"/>
             <p:cNvCxnSpPr/>
             <p:nvPr/>
           </p:nvCxnSpPr>
@@ -3890,7 +3855,7 @@
         </p:cxnSp>
         <p:cxnSp>
           <p:nvCxnSpPr>
-            <p:cNvPr id="23" name="Connector 22"/>
+            <p:cNvPr id="22" name="Connector 21"/>
             <p:cNvCxnSpPr/>
             <p:nvPr/>
           </p:nvCxnSpPr>
@@ -3925,7 +3890,7 @@
         </p:cxnSp>
         <p:cxnSp>
           <p:nvCxnSpPr>
-            <p:cNvPr id="24" name="Connector 23"/>
+            <p:cNvPr id="23" name="Connector 22"/>
             <p:cNvCxnSpPr/>
             <p:nvPr/>
           </p:nvCxnSpPr>
@@ -3960,7 +3925,7 @@
         </p:cxnSp>
         <p:cxnSp>
           <p:nvCxnSpPr>
-            <p:cNvPr id="25" name="Connector 24"/>
+            <p:cNvPr id="24" name="Connector 23"/>
             <p:cNvCxnSpPr/>
             <p:nvPr/>
           </p:nvCxnSpPr>
@@ -3996,7 +3961,7 @@
       </p:grpSp>
       <p:grpSp>
         <p:nvGrpSpPr>
-          <p:cNvPr id="26" name="Group 25"/>
+          <p:cNvPr id="25" name="Group 24"/>
           <p:cNvGrpSpPr/>
           <p:nvPr/>
         </p:nvGrpSpPr>
@@ -4010,7 +3975,7 @@
         </p:grpSpPr>
         <p:sp>
           <p:nvSpPr>
-            <p:cNvPr id="27" name="Rectangle 26"/>
+            <p:cNvPr id="26" name="Rectangle 25"/>
             <p:cNvSpPr/>
             <p:nvPr/>
           </p:nvSpPr>
@@ -4056,7 +4021,7 @@
         </p:sp>
         <p:cxnSp>
           <p:nvCxnSpPr>
-            <p:cNvPr id="28" name="Connector 27"/>
+            <p:cNvPr id="27" name="Connector 26"/>
             <p:cNvCxnSpPr/>
             <p:nvPr/>
           </p:nvCxnSpPr>
@@ -4091,7 +4056,7 @@
         </p:cxnSp>
         <p:cxnSp>
           <p:nvCxnSpPr>
-            <p:cNvPr id="29" name="Connector 28"/>
+            <p:cNvPr id="28" name="Connector 27"/>
             <p:cNvCxnSpPr/>
             <p:nvPr/>
           </p:nvCxnSpPr>
@@ -4126,7 +4091,7 @@
         </p:cxnSp>
         <p:cxnSp>
           <p:nvCxnSpPr>
-            <p:cNvPr id="30" name="Connector 29"/>
+            <p:cNvPr id="29" name="Connector 28"/>
             <p:cNvCxnSpPr/>
             <p:nvPr/>
           </p:nvCxnSpPr>
@@ -4161,7 +4126,7 @@
         </p:cxnSp>
         <p:cxnSp>
           <p:nvCxnSpPr>
-            <p:cNvPr id="31" name="Connector 30"/>
+            <p:cNvPr id="30" name="Connector 29"/>
             <p:cNvCxnSpPr/>
             <p:nvPr/>
           </p:nvCxnSpPr>
@@ -4196,7 +4161,7 @@
         </p:cxnSp>
         <p:cxnSp>
           <p:nvCxnSpPr>
-            <p:cNvPr id="32" name="Connector 31"/>
+            <p:cNvPr id="31" name="Connector 30"/>
             <p:cNvCxnSpPr/>
             <p:nvPr/>
           </p:nvCxnSpPr>
@@ -4231,7 +4196,7 @@
         </p:cxnSp>
         <p:cxnSp>
           <p:nvCxnSpPr>
-            <p:cNvPr id="33" name="Connector 32"/>
+            <p:cNvPr id="32" name="Connector 31"/>
             <p:cNvCxnSpPr/>
             <p:nvPr/>
           </p:nvCxnSpPr>
@@ -4267,7 +4232,7 @@
       </p:grpSp>
       <p:sp>
         <p:nvSpPr>
-          <p:cNvPr id="34" name="TextBox 33"/>
+          <p:cNvPr id="33" name="TextBox 32"/>
           <p:cNvSpPr txBox="1"/>
           <p:nvPr/>
         </p:nvSpPr>
@@ -4302,7 +4267,7 @@
       </p:sp>
       <p:grpSp>
         <p:nvGrpSpPr>
-          <p:cNvPr id="35" name="Group 34"/>
+          <p:cNvPr id="34" name="Group 33"/>
           <p:cNvGrpSpPr/>
           <p:nvPr/>
         </p:nvGrpSpPr>
@@ -4316,7 +4281,7 @@
         </p:grpSpPr>
         <p:sp>
           <p:nvSpPr>
-            <p:cNvPr id="36" name="Rectangle 35"/>
+            <p:cNvPr id="35" name="Rectangle 34"/>
             <p:cNvSpPr/>
             <p:nvPr/>
           </p:nvSpPr>
@@ -4362,7 +4327,7 @@
         </p:sp>
         <p:cxnSp>
           <p:nvCxnSpPr>
-            <p:cNvPr id="37" name="Connector 36"/>
+            <p:cNvPr id="36" name="Connector 35"/>
             <p:cNvCxnSpPr/>
             <p:nvPr/>
           </p:nvCxnSpPr>
@@ -4397,7 +4362,7 @@
         </p:cxnSp>
         <p:cxnSp>
           <p:nvCxnSpPr>
-            <p:cNvPr id="38" name="Connector 37"/>
+            <p:cNvPr id="37" name="Connector 36"/>
             <p:cNvCxnSpPr/>
             <p:nvPr/>
           </p:nvCxnSpPr>
@@ -4432,7 +4397,7 @@
         </p:cxnSp>
         <p:cxnSp>
           <p:nvCxnSpPr>
-            <p:cNvPr id="39" name="Connector 38"/>
+            <p:cNvPr id="38" name="Connector 37"/>
             <p:cNvCxnSpPr/>
             <p:nvPr/>
           </p:nvCxnSpPr>
@@ -4467,7 +4432,7 @@
         </p:cxnSp>
         <p:cxnSp>
           <p:nvCxnSpPr>
-            <p:cNvPr id="40" name="Connector 39"/>
+            <p:cNvPr id="39" name="Connector 38"/>
             <p:cNvCxnSpPr/>
             <p:nvPr/>
           </p:nvCxnSpPr>
@@ -4502,7 +4467,7 @@
         </p:cxnSp>
         <p:cxnSp>
           <p:nvCxnSpPr>
-            <p:cNvPr id="41" name="Connector 40"/>
+            <p:cNvPr id="40" name="Connector 39"/>
             <p:cNvCxnSpPr/>
             <p:nvPr/>
           </p:nvCxnSpPr>
@@ -4537,7 +4502,7 @@
         </p:cxnSp>
         <p:cxnSp>
           <p:nvCxnSpPr>
-            <p:cNvPr id="42" name="Connector 41"/>
+            <p:cNvPr id="41" name="Connector 40"/>
             <p:cNvCxnSpPr/>
             <p:nvPr/>
           </p:nvCxnSpPr>
@@ -4573,7 +4538,7 @@
       </p:grpSp>
       <p:sp>
         <p:nvSpPr>
-          <p:cNvPr id="43" name="Right Bracket 42"/>
+          <p:cNvPr id="42" name="Right Bracket 41"/>
           <p:cNvSpPr/>
           <p:nvPr/>
         </p:nvSpPr>
@@ -4615,44 +4580,9 @@
           </a:p>
         </p:txBody>
       </p:sp>
-      <p:sp>
-        <p:nvSpPr>
-          <p:cNvPr id="44" name="TextBox 43"/>
-          <p:cNvSpPr txBox="1"/>
-          <p:nvPr/>
-        </p:nvSpPr>
-        <p:spPr>
-          <a:xfrm>
-            <a:off x="3761999" y="1314000"/>
-            <a:ext cx="2088000" cy="144000"/>
-          </a:xfrm>
-          <a:prstGeom prst="rect">
-            <a:avLst/>
-          </a:prstGeom>
-          <a:noFill/>
-        </p:spPr>
-        <p:txBody>
-          <a:bodyPr wrap="square" lIns="0" rIns="0" tIns="0" bIns="0" anchor="ctr">
-            <a:spAutoFit/>
-          </a:bodyPr>
-          <a:lstStyle/>
-          <a:p>
-            <a:pPr algn="ctr"/>
-            <a:r>
-              <a:rPr sz="900" b="0" i="0">
-                <a:solidFill>
-                  <a:srgbClr val="6B7385"/>
-                </a:solidFill>
-                <a:latin typeface="Work Sans"/>
-              </a:rPr>
-              <a:t>layers 2 / 5 / 8  +  latent</a:t>
-            </a:r>
-          </a:p>
-        </p:txBody>
-      </p:sp>
       <p:cxnSp>
         <p:nvCxnSpPr>
-          <p:cNvPr id="45" name="Connector 44"/>
+          <p:cNvPr id="43" name="Connector 42"/>
           <p:cNvCxnSpPr/>
           <p:nvPr/>
         </p:nvCxnSpPr>
@@ -4687,7 +4617,7 @@
       </p:cxnSp>
       <p:cxnSp>
         <p:nvCxnSpPr>
-          <p:cNvPr id="46" name="Connector 45"/>
+          <p:cNvPr id="44" name="Connector 43"/>
           <p:cNvCxnSpPr/>
           <p:nvPr/>
         </p:nvCxnSpPr>
@@ -4722,7 +4652,7 @@
       </p:cxnSp>
       <p:cxnSp>
         <p:nvCxnSpPr>
-          <p:cNvPr id="47" name="Connector 46"/>
+          <p:cNvPr id="45" name="Connector 44"/>
           <p:cNvCxnSpPr/>
           <p:nvPr/>
         </p:nvCxnSpPr>
@@ -4757,7 +4687,7 @@
       </p:cxnSp>
       <p:cxnSp>
         <p:nvCxnSpPr>
-          <p:cNvPr id="48" name="Connector 47"/>
+          <p:cNvPr id="46" name="Connector 45"/>
           <p:cNvCxnSpPr/>
           <p:nvPr/>
         </p:nvCxnSpPr>
@@ -4792,7 +4722,7 @@
       </p:cxnSp>
       <p:cxnSp>
         <p:nvCxnSpPr>
-          <p:cNvPr id="49" name="Connector 48"/>
+          <p:cNvPr id="47" name="Connector 46"/>
           <p:cNvCxnSpPr/>
           <p:nvPr/>
         </p:nvCxnSpPr>
@@ -4828,7 +4758,7 @@
       </p:cxnSp>
       <p:sp>
         <p:nvSpPr>
-          <p:cNvPr id="50" name="Rounded Rectangle 49"/>
+          <p:cNvPr id="48" name="Rounded Rectangle 47"/>
           <p:cNvSpPr/>
           <p:nvPr/>
         </p:nvSpPr>
@@ -4874,7 +4804,7 @@
       </p:sp>
       <p:sp>
         <p:nvSpPr>
-          <p:cNvPr id="51" name="TextBox 50"/>
+          <p:cNvPr id="49" name="TextBox 48"/>
           <p:cNvSpPr txBox="1"/>
           <p:nvPr/>
         </p:nvSpPr>
@@ -4909,7 +4839,7 @@
       </p:sp>
       <p:grpSp>
         <p:nvGrpSpPr>
-          <p:cNvPr id="52" name="Group 51"/>
+          <p:cNvPr id="50" name="Group 49"/>
           <p:cNvGrpSpPr/>
           <p:nvPr/>
         </p:nvGrpSpPr>
@@ -4923,7 +4853,7 @@
         </p:grpSpPr>
         <p:sp>
           <p:nvSpPr>
-            <p:cNvPr id="53" name="Rectangle 52"/>
+            <p:cNvPr id="51" name="Rectangle 50"/>
             <p:cNvSpPr/>
             <p:nvPr/>
           </p:nvSpPr>
@@ -4969,7 +4899,7 @@
         </p:sp>
         <p:cxnSp>
           <p:nvCxnSpPr>
-            <p:cNvPr id="54" name="Connector 53"/>
+            <p:cNvPr id="52" name="Connector 51"/>
             <p:cNvCxnSpPr/>
             <p:nvPr/>
           </p:nvCxnSpPr>
@@ -5004,7 +4934,7 @@
         </p:cxnSp>
         <p:cxnSp>
           <p:nvCxnSpPr>
-            <p:cNvPr id="55" name="Connector 54"/>
+            <p:cNvPr id="53" name="Connector 52"/>
             <p:cNvCxnSpPr/>
             <p:nvPr/>
           </p:nvCxnSpPr>
@@ -5039,7 +4969,7 @@
         </p:cxnSp>
         <p:cxnSp>
           <p:nvCxnSpPr>
-            <p:cNvPr id="56" name="Connector 55"/>
+            <p:cNvPr id="54" name="Connector 53"/>
             <p:cNvCxnSpPr/>
             <p:nvPr/>
           </p:nvCxnSpPr>
@@ -5074,7 +5004,7 @@
         </p:cxnSp>
         <p:cxnSp>
           <p:nvCxnSpPr>
-            <p:cNvPr id="57" name="Connector 56"/>
+            <p:cNvPr id="55" name="Connector 54"/>
             <p:cNvCxnSpPr/>
             <p:nvPr/>
           </p:nvCxnSpPr>
@@ -5109,7 +5039,7 @@
         </p:cxnSp>
         <p:cxnSp>
           <p:nvCxnSpPr>
-            <p:cNvPr id="58" name="Connector 57"/>
+            <p:cNvPr id="56" name="Connector 55"/>
             <p:cNvCxnSpPr/>
             <p:nvPr/>
           </p:nvCxnSpPr>
@@ -5144,7 +5074,7 @@
         </p:cxnSp>
         <p:cxnSp>
           <p:nvCxnSpPr>
-            <p:cNvPr id="59" name="Connector 58"/>
+            <p:cNvPr id="57" name="Connector 56"/>
             <p:cNvCxnSpPr/>
             <p:nvPr/>
           </p:nvCxnSpPr>
@@ -5180,7 +5110,7 @@
       </p:grpSp>
       <p:grpSp>
         <p:nvGrpSpPr>
-          <p:cNvPr id="60" name="Group 59"/>
+          <p:cNvPr id="58" name="Group 57"/>
           <p:cNvGrpSpPr/>
           <p:nvPr/>
         </p:nvGrpSpPr>
@@ -5194,7 +5124,7 @@
         </p:grpSpPr>
         <p:sp>
           <p:nvSpPr>
-            <p:cNvPr id="61" name="Rectangle 60"/>
+            <p:cNvPr id="59" name="Rectangle 58"/>
             <p:cNvSpPr/>
             <p:nvPr/>
           </p:nvSpPr>
@@ -5240,7 +5170,7 @@
         </p:sp>
         <p:cxnSp>
           <p:nvCxnSpPr>
-            <p:cNvPr id="62" name="Connector 61"/>
+            <p:cNvPr id="60" name="Connector 59"/>
             <p:cNvCxnSpPr/>
             <p:nvPr/>
           </p:nvCxnSpPr>
@@ -5275,7 +5205,7 @@
         </p:cxnSp>
         <p:cxnSp>
           <p:nvCxnSpPr>
-            <p:cNvPr id="63" name="Connector 62"/>
+            <p:cNvPr id="61" name="Connector 60"/>
             <p:cNvCxnSpPr/>
             <p:nvPr/>
           </p:nvCxnSpPr>
@@ -5310,7 +5240,7 @@
         </p:cxnSp>
         <p:cxnSp>
           <p:nvCxnSpPr>
-            <p:cNvPr id="64" name="Connector 63"/>
+            <p:cNvPr id="62" name="Connector 61"/>
             <p:cNvCxnSpPr/>
             <p:nvPr/>
           </p:nvCxnSpPr>
@@ -5345,7 +5275,7 @@
         </p:cxnSp>
         <p:cxnSp>
           <p:nvCxnSpPr>
-            <p:cNvPr id="65" name="Connector 64"/>
+            <p:cNvPr id="63" name="Connector 62"/>
             <p:cNvCxnSpPr/>
             <p:nvPr/>
           </p:nvCxnSpPr>
@@ -5380,7 +5310,7 @@
         </p:cxnSp>
         <p:cxnSp>
           <p:nvCxnSpPr>
-            <p:cNvPr id="66" name="Connector 65"/>
+            <p:cNvPr id="64" name="Connector 63"/>
             <p:cNvCxnSpPr/>
             <p:nvPr/>
           </p:nvCxnSpPr>
@@ -5415,7 +5345,7 @@
         </p:cxnSp>
         <p:cxnSp>
           <p:nvCxnSpPr>
-            <p:cNvPr id="67" name="Connector 66"/>
+            <p:cNvPr id="65" name="Connector 64"/>
             <p:cNvCxnSpPr/>
             <p:nvPr/>
           </p:nvCxnSpPr>
@@ -5451,7 +5381,7 @@
       </p:grpSp>
       <p:grpSp>
         <p:nvGrpSpPr>
-          <p:cNvPr id="68" name="Group 67"/>
+          <p:cNvPr id="66" name="Group 65"/>
           <p:cNvGrpSpPr/>
           <p:nvPr/>
         </p:nvGrpSpPr>
@@ -5465,7 +5395,7 @@
         </p:grpSpPr>
         <p:sp>
           <p:nvSpPr>
-            <p:cNvPr id="69" name="Rectangle 68"/>
+            <p:cNvPr id="67" name="Rectangle 66"/>
             <p:cNvSpPr/>
             <p:nvPr/>
           </p:nvSpPr>
@@ -5511,7 +5441,7 @@
         </p:sp>
         <p:cxnSp>
           <p:nvCxnSpPr>
-            <p:cNvPr id="70" name="Connector 69"/>
+            <p:cNvPr id="68" name="Connector 67"/>
             <p:cNvCxnSpPr/>
             <p:nvPr/>
           </p:nvCxnSpPr>
@@ -5546,7 +5476,7 @@
         </p:cxnSp>
         <p:cxnSp>
           <p:nvCxnSpPr>
-            <p:cNvPr id="71" name="Connector 70"/>
+            <p:cNvPr id="69" name="Connector 68"/>
             <p:cNvCxnSpPr/>
             <p:nvPr/>
           </p:nvCxnSpPr>
@@ -5581,7 +5511,7 @@
         </p:cxnSp>
         <p:cxnSp>
           <p:nvCxnSpPr>
-            <p:cNvPr id="72" name="Connector 71"/>
+            <p:cNvPr id="70" name="Connector 69"/>
             <p:cNvCxnSpPr/>
             <p:nvPr/>
           </p:nvCxnSpPr>
@@ -5616,7 +5546,7 @@
         </p:cxnSp>
         <p:cxnSp>
           <p:nvCxnSpPr>
-            <p:cNvPr id="73" name="Connector 72"/>
+            <p:cNvPr id="71" name="Connector 70"/>
             <p:cNvCxnSpPr/>
             <p:nvPr/>
           </p:nvCxnSpPr>
@@ -5651,7 +5581,7 @@
         </p:cxnSp>
         <p:cxnSp>
           <p:nvCxnSpPr>
-            <p:cNvPr id="74" name="Connector 73"/>
+            <p:cNvPr id="72" name="Connector 71"/>
             <p:cNvCxnSpPr/>
             <p:nvPr/>
           </p:nvCxnSpPr>
@@ -5686,7 +5616,7 @@
         </p:cxnSp>
         <p:cxnSp>
           <p:nvCxnSpPr>
-            <p:cNvPr id="75" name="Connector 74"/>
+            <p:cNvPr id="73" name="Connector 72"/>
             <p:cNvCxnSpPr/>
             <p:nvPr/>
           </p:nvCxnSpPr>
@@ -5722,7 +5652,7 @@
       </p:grpSp>
       <p:cxnSp>
         <p:nvCxnSpPr>
-          <p:cNvPr id="76" name="Connector 75"/>
+          <p:cNvPr id="74" name="Connector 73"/>
           <p:cNvCxnSpPr/>
           <p:nvPr/>
         </p:nvCxnSpPr>
@@ -5758,7 +5688,7 @@
       </p:cxnSp>
       <p:sp>
         <p:nvSpPr>
-          <p:cNvPr id="77" name="Rounded Rectangle 76"/>
+          <p:cNvPr id="75" name="Rounded Rectangle 74"/>
           <p:cNvSpPr/>
           <p:nvPr/>
         </p:nvSpPr>
@@ -5827,7 +5757,7 @@
       </p:sp>
       <p:cxnSp>
         <p:nvCxnSpPr>
-          <p:cNvPr id="78" name="Connector 77"/>
+          <p:cNvPr id="76" name="Connector 75"/>
           <p:cNvCxnSpPr/>
           <p:nvPr/>
         </p:nvCxnSpPr>
@@ -5863,7 +5793,7 @@
       </p:cxnSp>
       <p:grpSp>
         <p:nvGrpSpPr>
-          <p:cNvPr id="79" name="Group 78"/>
+          <p:cNvPr id="77" name="Group 76"/>
           <p:cNvGrpSpPr/>
           <p:nvPr/>
         </p:nvGrpSpPr>
@@ -5877,7 +5807,7 @@
         </p:grpSpPr>
         <p:sp>
           <p:nvSpPr>
-            <p:cNvPr id="80" name="Rectangle 79"/>
+            <p:cNvPr id="78" name="Rectangle 77"/>
             <p:cNvSpPr/>
             <p:nvPr/>
           </p:nvSpPr>
@@ -5923,7 +5853,7 @@
         </p:sp>
         <p:cxnSp>
           <p:nvCxnSpPr>
-            <p:cNvPr id="81" name="Connector 80"/>
+            <p:cNvPr id="79" name="Connector 78"/>
             <p:cNvCxnSpPr/>
             <p:nvPr/>
           </p:nvCxnSpPr>
@@ -5958,7 +5888,7 @@
         </p:cxnSp>
         <p:cxnSp>
           <p:nvCxnSpPr>
-            <p:cNvPr id="82" name="Connector 81"/>
+            <p:cNvPr id="80" name="Connector 79"/>
             <p:cNvCxnSpPr/>
             <p:nvPr/>
           </p:nvCxnSpPr>
@@ -5993,7 +5923,7 @@
         </p:cxnSp>
         <p:cxnSp>
           <p:nvCxnSpPr>
-            <p:cNvPr id="83" name="Connector 82"/>
+            <p:cNvPr id="81" name="Connector 80"/>
             <p:cNvCxnSpPr/>
             <p:nvPr/>
           </p:nvCxnSpPr>
@@ -6028,7 +5958,7 @@
         </p:cxnSp>
         <p:cxnSp>
           <p:nvCxnSpPr>
-            <p:cNvPr id="84" name="Connector 83"/>
+            <p:cNvPr id="82" name="Connector 81"/>
             <p:cNvCxnSpPr/>
             <p:nvPr/>
           </p:nvCxnSpPr>
@@ -6063,7 +5993,7 @@
         </p:cxnSp>
         <p:cxnSp>
           <p:nvCxnSpPr>
-            <p:cNvPr id="85" name="Connector 84"/>
+            <p:cNvPr id="83" name="Connector 82"/>
             <p:cNvCxnSpPr/>
             <p:nvPr/>
           </p:nvCxnSpPr>
@@ -6098,7 +6028,7 @@
         </p:cxnSp>
         <p:cxnSp>
           <p:nvCxnSpPr>
-            <p:cNvPr id="86" name="Connector 85"/>
+            <p:cNvPr id="84" name="Connector 83"/>
             <p:cNvCxnSpPr/>
             <p:nvPr/>
           </p:nvCxnSpPr>
@@ -6134,7 +6064,7 @@
       </p:grpSp>
       <p:grpSp>
         <p:nvGrpSpPr>
-          <p:cNvPr id="87" name="Group 86"/>
+          <p:cNvPr id="85" name="Group 84"/>
           <p:cNvGrpSpPr/>
           <p:nvPr/>
         </p:nvGrpSpPr>
@@ -6148,7 +6078,7 @@
         </p:grpSpPr>
         <p:sp>
           <p:nvSpPr>
-            <p:cNvPr id="88" name="Rectangle 87"/>
+            <p:cNvPr id="86" name="Rectangle 85"/>
             <p:cNvSpPr/>
             <p:nvPr/>
           </p:nvSpPr>
@@ -6194,7 +6124,7 @@
         </p:sp>
         <p:cxnSp>
           <p:nvCxnSpPr>
-            <p:cNvPr id="89" name="Connector 88"/>
+            <p:cNvPr id="87" name="Connector 86"/>
             <p:cNvCxnSpPr/>
             <p:nvPr/>
           </p:nvCxnSpPr>
@@ -6229,7 +6159,7 @@
         </p:cxnSp>
         <p:cxnSp>
           <p:nvCxnSpPr>
-            <p:cNvPr id="90" name="Connector 89"/>
+            <p:cNvPr id="88" name="Connector 87"/>
             <p:cNvCxnSpPr/>
             <p:nvPr/>
           </p:nvCxnSpPr>
@@ -6264,7 +6194,7 @@
         </p:cxnSp>
         <p:cxnSp>
           <p:nvCxnSpPr>
-            <p:cNvPr id="91" name="Connector 90"/>
+            <p:cNvPr id="89" name="Connector 88"/>
             <p:cNvCxnSpPr/>
             <p:nvPr/>
           </p:nvCxnSpPr>
@@ -6299,7 +6229,7 @@
         </p:cxnSp>
         <p:cxnSp>
           <p:nvCxnSpPr>
-            <p:cNvPr id="92" name="Connector 91"/>
+            <p:cNvPr id="90" name="Connector 89"/>
             <p:cNvCxnSpPr/>
             <p:nvPr/>
           </p:nvCxnSpPr>
@@ -6334,7 +6264,7 @@
         </p:cxnSp>
         <p:cxnSp>
           <p:nvCxnSpPr>
-            <p:cNvPr id="93" name="Connector 92"/>
+            <p:cNvPr id="91" name="Connector 90"/>
             <p:cNvCxnSpPr/>
             <p:nvPr/>
           </p:nvCxnSpPr>
@@ -6369,7 +6299,7 @@
         </p:cxnSp>
         <p:cxnSp>
           <p:nvCxnSpPr>
-            <p:cNvPr id="94" name="Connector 93"/>
+            <p:cNvPr id="92" name="Connector 91"/>
             <p:cNvCxnSpPr/>
             <p:nvPr/>
           </p:nvCxnSpPr>
@@ -6405,7 +6335,7 @@
       </p:grpSp>
       <p:grpSp>
         <p:nvGrpSpPr>
-          <p:cNvPr id="95" name="Group 94"/>
+          <p:cNvPr id="93" name="Group 92"/>
           <p:cNvGrpSpPr/>
           <p:nvPr/>
         </p:nvGrpSpPr>
@@ -6419,7 +6349,7 @@
         </p:grpSpPr>
         <p:sp>
           <p:nvSpPr>
-            <p:cNvPr id="96" name="Rectangle 95"/>
+            <p:cNvPr id="94" name="Rectangle 93"/>
             <p:cNvSpPr/>
             <p:nvPr/>
           </p:nvSpPr>
@@ -6465,7 +6395,7 @@
         </p:sp>
         <p:cxnSp>
           <p:nvCxnSpPr>
-            <p:cNvPr id="97" name="Connector 96"/>
+            <p:cNvPr id="95" name="Connector 94"/>
             <p:cNvCxnSpPr/>
             <p:nvPr/>
           </p:nvCxnSpPr>
@@ -6500,7 +6430,7 @@
         </p:cxnSp>
         <p:cxnSp>
           <p:nvCxnSpPr>
-            <p:cNvPr id="98" name="Connector 97"/>
+            <p:cNvPr id="96" name="Connector 95"/>
             <p:cNvCxnSpPr/>
             <p:nvPr/>
           </p:nvCxnSpPr>
@@ -6535,7 +6465,7 @@
         </p:cxnSp>
         <p:cxnSp>
           <p:nvCxnSpPr>
-            <p:cNvPr id="99" name="Connector 98"/>
+            <p:cNvPr id="97" name="Connector 96"/>
             <p:cNvCxnSpPr/>
             <p:nvPr/>
           </p:nvCxnSpPr>
@@ -6570,7 +6500,7 @@
         </p:cxnSp>
         <p:cxnSp>
           <p:nvCxnSpPr>
-            <p:cNvPr id="100" name="Connector 99"/>
+            <p:cNvPr id="98" name="Connector 97"/>
             <p:cNvCxnSpPr/>
             <p:nvPr/>
           </p:nvCxnSpPr>
@@ -6605,7 +6535,7 @@
         </p:cxnSp>
         <p:cxnSp>
           <p:nvCxnSpPr>
-            <p:cNvPr id="101" name="Connector 100"/>
+            <p:cNvPr id="99" name="Connector 98"/>
             <p:cNvCxnSpPr/>
             <p:nvPr/>
           </p:nvCxnSpPr>
@@ -6640,7 +6570,7 @@
         </p:cxnSp>
         <p:cxnSp>
           <p:nvCxnSpPr>
-            <p:cNvPr id="102" name="Connector 101"/>
+            <p:cNvPr id="100" name="Connector 99"/>
             <p:cNvCxnSpPr/>
             <p:nvPr/>
           </p:nvCxnSpPr>
@@ -6676,7 +6606,7 @@
       </p:grpSp>
       <p:cxnSp>
         <p:nvCxnSpPr>
-          <p:cNvPr id="103" name="Connector 102"/>
+          <p:cNvPr id="101" name="Connector 100"/>
           <p:cNvCxnSpPr/>
           <p:nvPr/>
         </p:nvCxnSpPr>
@@ -6712,7 +6642,7 @@
       </p:cxnSp>
       <p:sp>
         <p:nvSpPr>
-          <p:cNvPr id="104" name="Rounded Rectangle 103"/>
+          <p:cNvPr id="102" name="Rounded Rectangle 101"/>
           <p:cNvSpPr/>
           <p:nvPr/>
         </p:nvSpPr>
@@ -6781,7 +6711,7 @@
       </p:sp>
       <p:sp>
         <p:nvSpPr>
-          <p:cNvPr id="105" name="TextBox 104"/>
+          <p:cNvPr id="103" name="TextBox 102"/>
           <p:cNvSpPr txBox="1"/>
           <p:nvPr/>
         </p:nvSpPr>
@@ -6816,7 +6746,7 @@
       </p:sp>
       <p:cxnSp>
         <p:nvCxnSpPr>
-          <p:cNvPr id="106" name="Connector 105"/>
+          <p:cNvPr id="104" name="Connector 103"/>
           <p:cNvCxnSpPr/>
           <p:nvPr/>
         </p:nvCxnSpPr>
@@ -6852,7 +6782,7 @@
       </p:cxnSp>
       <p:cxnSp>
         <p:nvCxnSpPr>
-          <p:cNvPr id="107" name="Connector 106"/>
+          <p:cNvPr id="105" name="Connector 104"/>
           <p:cNvCxnSpPr/>
           <p:nvPr/>
         </p:nvCxnSpPr>
@@ -6888,7 +6818,7 @@
       </p:cxnSp>
       <p:sp>
         <p:nvSpPr>
-          <p:cNvPr id="108" name="TextBox 107"/>
+          <p:cNvPr id="106" name="TextBox 105"/>
           <p:cNvSpPr txBox="1"/>
           <p:nvPr/>
         </p:nvSpPr>

</xml_diff>